<commit_message>
add img fix bugs
</commit_message>
<xml_diff>
--- a/doc/簡報1.pptx
+++ b/doc/簡報1.pptx
@@ -8,6 +8,7 @@
     <p:sldId id="256" r:id="rId2"/>
     <p:sldId id="257" r:id="rId3"/>
     <p:sldId id="258" r:id="rId4"/>
+    <p:sldId id="259" r:id="rId5"/>
   </p:sldIdLst>
   <p:sldSz cx="12192000" cy="6858000"/>
   <p:notesSz cx="6858000" cy="9144000"/>
@@ -5865,8 +5866,8 @@
         </p:blipFill>
         <p:spPr>
           <a:xfrm>
-            <a:off x="4859841" y="3823401"/>
-            <a:ext cx="394769" cy="394769"/>
+            <a:off x="4934557" y="3898117"/>
+            <a:ext cx="320053" cy="320053"/>
           </a:xfrm>
           <a:prstGeom prst="rect">
             <a:avLst/>
@@ -5904,7 +5905,7 @@
         </p:blipFill>
         <p:spPr>
           <a:xfrm>
-            <a:off x="2437261" y="4343388"/>
+            <a:off x="3264032" y="4218170"/>
             <a:ext cx="641714" cy="641714"/>
           </a:xfrm>
           <a:prstGeom prst="rect">
@@ -6731,6 +6732,502 @@
     <p:extLst>
       <p:ext uri="{BB962C8B-B14F-4D97-AF65-F5344CB8AC3E}">
         <p14:creationId xmlns:p14="http://schemas.microsoft.com/office/powerpoint/2010/main" val="955809027"/>
+      </p:ext>
+    </p:extLst>
+  </p:cSld>
+  <p:clrMapOvr>
+    <a:masterClrMapping/>
+  </p:clrMapOvr>
+</p:sld>
+</file>
+
+<file path=ppt/slides/slide4.xml><?xml version="1.0" encoding="utf-8"?>
+<p:sld xmlns:a="http://schemas.openxmlformats.org/drawingml/2006/main" xmlns:r="http://schemas.openxmlformats.org/officeDocument/2006/relationships" xmlns:p="http://schemas.openxmlformats.org/presentationml/2006/main">
+  <p:cSld>
+    <p:bg>
+      <p:bgPr>
+        <a:solidFill>
+          <a:schemeClr val="accent6">
+            <a:lumMod val="40000"/>
+            <a:lumOff val="60000"/>
+          </a:schemeClr>
+        </a:solidFill>
+        <a:effectLst/>
+      </p:bgPr>
+    </p:bg>
+    <p:spTree>
+      <p:nvGrpSpPr>
+        <p:cNvPr id="1" name=""/>
+        <p:cNvGrpSpPr/>
+        <p:nvPr/>
+      </p:nvGrpSpPr>
+      <p:grpSpPr>
+        <a:xfrm>
+          <a:off x="0" y="0"/>
+          <a:ext cx="0" cy="0"/>
+          <a:chOff x="0" y="0"/>
+          <a:chExt cx="0" cy="0"/>
+        </a:xfrm>
+      </p:grpSpPr>
+      <p:pic>
+        <p:nvPicPr>
+          <p:cNvPr id="2" name="圖形 1" descr="貓 以實心填滿">
+            <a:extLst>
+              <a:ext uri="{FF2B5EF4-FFF2-40B4-BE49-F238E27FC236}">
+                <a16:creationId xmlns:a16="http://schemas.microsoft.com/office/drawing/2014/main" id="{91515F68-40AA-4724-8295-1CF783599559}"/>
+              </a:ext>
+            </a:extLst>
+          </p:cNvPr>
+          <p:cNvPicPr>
+            <a:picLocks noChangeAspect="1"/>
+          </p:cNvPicPr>
+          <p:nvPr/>
+        </p:nvPicPr>
+        <p:blipFill>
+          <a:blip r:embed="rId2">
+            <a:extLst>
+              <a:ext uri="{28A0092B-C50C-407E-A947-70E740481C1C}">
+                <a14:useLocalDpi xmlns:a14="http://schemas.microsoft.com/office/drawing/2010/main" val="0"/>
+              </a:ext>
+              <a:ext uri="{96DAC541-7B7A-43D3-8B79-37D633B846F1}">
+                <asvg:svgBlip xmlns:asvg="http://schemas.microsoft.com/office/drawing/2016/SVG/main" r:embed="rId3"/>
+              </a:ext>
+            </a:extLst>
+          </a:blip>
+          <a:stretch>
+            <a:fillRect/>
+          </a:stretch>
+        </p:blipFill>
+        <p:spPr>
+          <a:xfrm>
+            <a:off x="2648040" y="3951310"/>
+            <a:ext cx="421218" cy="406459"/>
+          </a:xfrm>
+          <a:prstGeom prst="rect">
+            <a:avLst/>
+          </a:prstGeom>
+        </p:spPr>
+      </p:pic>
+      <p:pic>
+        <p:nvPicPr>
+          <p:cNvPr id="3" name="圖形 2" descr="貓 以實心填滿">
+            <a:extLst>
+              <a:ext uri="{FF2B5EF4-FFF2-40B4-BE49-F238E27FC236}">
+                <a16:creationId xmlns:a16="http://schemas.microsoft.com/office/drawing/2014/main" id="{99A4C52C-0F43-428C-B6B0-CDB725B3355C}"/>
+              </a:ext>
+            </a:extLst>
+          </p:cNvPr>
+          <p:cNvPicPr>
+            <a:picLocks noChangeAspect="1"/>
+          </p:cNvPicPr>
+          <p:nvPr/>
+        </p:nvPicPr>
+        <p:blipFill>
+          <a:blip r:embed="rId4">
+            <a:extLst>
+              <a:ext uri="{28A0092B-C50C-407E-A947-70E740481C1C}">
+                <a14:useLocalDpi xmlns:a14="http://schemas.microsoft.com/office/drawing/2010/main" val="0"/>
+              </a:ext>
+              <a:ext uri="{96DAC541-7B7A-43D3-8B79-37D633B846F1}">
+                <asvg:svgBlip xmlns:asvg="http://schemas.microsoft.com/office/drawing/2016/SVG/main" r:embed="rId5"/>
+              </a:ext>
+            </a:extLst>
+          </a:blip>
+          <a:stretch>
+            <a:fillRect/>
+          </a:stretch>
+        </p:blipFill>
+        <p:spPr>
+          <a:xfrm>
+            <a:off x="3226119" y="3959636"/>
+            <a:ext cx="421218" cy="406459"/>
+          </a:xfrm>
+          <a:prstGeom prst="rect">
+            <a:avLst/>
+          </a:prstGeom>
+        </p:spPr>
+      </p:pic>
+      <p:pic>
+        <p:nvPicPr>
+          <p:cNvPr id="4" name="圖形 3" descr="貓 以實心填滿">
+            <a:extLst>
+              <a:ext uri="{FF2B5EF4-FFF2-40B4-BE49-F238E27FC236}">
+                <a16:creationId xmlns:a16="http://schemas.microsoft.com/office/drawing/2014/main" id="{2FDFC8B0-15AA-482A-9E37-23D76BDAF830}"/>
+              </a:ext>
+            </a:extLst>
+          </p:cNvPr>
+          <p:cNvPicPr>
+            <a:picLocks noChangeAspect="1"/>
+          </p:cNvPicPr>
+          <p:nvPr/>
+        </p:nvPicPr>
+        <p:blipFill>
+          <a:blip r:embed="rId6">
+            <a:extLst>
+              <a:ext uri="{28A0092B-C50C-407E-A947-70E740481C1C}">
+                <a14:useLocalDpi xmlns:a14="http://schemas.microsoft.com/office/drawing/2010/main" val="0"/>
+              </a:ext>
+              <a:ext uri="{96DAC541-7B7A-43D3-8B79-37D633B846F1}">
+                <asvg:svgBlip xmlns:asvg="http://schemas.microsoft.com/office/drawing/2016/SVG/main" r:embed="rId7"/>
+              </a:ext>
+            </a:extLst>
+          </a:blip>
+          <a:stretch>
+            <a:fillRect/>
+          </a:stretch>
+        </p:blipFill>
+        <p:spPr>
+          <a:xfrm>
+            <a:off x="3730157" y="3951309"/>
+            <a:ext cx="421218" cy="406459"/>
+          </a:xfrm>
+          <a:prstGeom prst="rect">
+            <a:avLst/>
+          </a:prstGeom>
+        </p:spPr>
+      </p:pic>
+      <p:pic>
+        <p:nvPicPr>
+          <p:cNvPr id="5" name="圖形 4" descr="貓 以實心填滿">
+            <a:extLst>
+              <a:ext uri="{FF2B5EF4-FFF2-40B4-BE49-F238E27FC236}">
+                <a16:creationId xmlns:a16="http://schemas.microsoft.com/office/drawing/2014/main" id="{61F40244-D6E8-4E50-B3F8-BE9E8B9EF081}"/>
+              </a:ext>
+            </a:extLst>
+          </p:cNvPr>
+          <p:cNvPicPr>
+            <a:picLocks noChangeAspect="1"/>
+          </p:cNvPicPr>
+          <p:nvPr/>
+        </p:nvPicPr>
+        <p:blipFill>
+          <a:blip r:embed="rId8">
+            <a:extLst>
+              <a:ext uri="{28A0092B-C50C-407E-A947-70E740481C1C}">
+                <a14:useLocalDpi xmlns:a14="http://schemas.microsoft.com/office/drawing/2010/main" val="0"/>
+              </a:ext>
+              <a:ext uri="{96DAC541-7B7A-43D3-8B79-37D633B846F1}">
+                <asvg:svgBlip xmlns:asvg="http://schemas.microsoft.com/office/drawing/2016/SVG/main" r:embed="rId9"/>
+              </a:ext>
+            </a:extLst>
+          </a:blip>
+          <a:stretch>
+            <a:fillRect/>
+          </a:stretch>
+        </p:blipFill>
+        <p:spPr>
+          <a:xfrm>
+            <a:off x="2144002" y="3965475"/>
+            <a:ext cx="421218" cy="406459"/>
+          </a:xfrm>
+          <a:prstGeom prst="rect">
+            <a:avLst/>
+          </a:prstGeom>
+        </p:spPr>
+      </p:pic>
+      <p:pic>
+        <p:nvPicPr>
+          <p:cNvPr id="6" name="圖形 5" descr="貓 以實心填滿">
+            <a:extLst>
+              <a:ext uri="{FF2B5EF4-FFF2-40B4-BE49-F238E27FC236}">
+                <a16:creationId xmlns:a16="http://schemas.microsoft.com/office/drawing/2014/main" id="{634ECC27-63BE-493C-AAFC-A280AAB54A35}"/>
+              </a:ext>
+            </a:extLst>
+          </p:cNvPr>
+          <p:cNvPicPr>
+            <a:picLocks noChangeAspect="1"/>
+          </p:cNvPicPr>
+          <p:nvPr/>
+        </p:nvPicPr>
+        <p:blipFill>
+          <a:blip r:embed="rId10">
+            <a:extLst>
+              <a:ext uri="{28A0092B-C50C-407E-A947-70E740481C1C}">
+                <a14:useLocalDpi xmlns:a14="http://schemas.microsoft.com/office/drawing/2010/main" val="0"/>
+              </a:ext>
+              <a:ext uri="{96DAC541-7B7A-43D3-8B79-37D633B846F1}">
+                <asvg:svgBlip xmlns:asvg="http://schemas.microsoft.com/office/drawing/2016/SVG/main" r:embed="rId11"/>
+              </a:ext>
+            </a:extLst>
+          </a:blip>
+          <a:stretch>
+            <a:fillRect/>
+          </a:stretch>
+        </p:blipFill>
+        <p:spPr>
+          <a:xfrm>
+            <a:off x="4234195" y="3951310"/>
+            <a:ext cx="421218" cy="406459"/>
+          </a:xfrm>
+          <a:prstGeom prst="rect">
+            <a:avLst/>
+          </a:prstGeom>
+        </p:spPr>
+      </p:pic>
+      <p:sp>
+        <p:nvSpPr>
+          <p:cNvPr id="7" name="橢圓 6">
+            <a:extLst>
+              <a:ext uri="{FF2B5EF4-FFF2-40B4-BE49-F238E27FC236}">
+                <a16:creationId xmlns:a16="http://schemas.microsoft.com/office/drawing/2014/main" id="{7D2D0D50-71A9-4462-B002-B52304814F9D}"/>
+              </a:ext>
+            </a:extLst>
+          </p:cNvPr>
+          <p:cNvSpPr/>
+          <p:nvPr/>
+        </p:nvSpPr>
+        <p:spPr>
+          <a:xfrm>
+            <a:off x="2330592" y="4153067"/>
+            <a:ext cx="64195" cy="130629"/>
+          </a:xfrm>
+          <a:prstGeom prst="ellipse">
+            <a:avLst/>
+          </a:prstGeom>
+          <a:solidFill>
+            <a:srgbClr val="A5A5A5"/>
+          </a:solidFill>
+          <a:ln>
+            <a:noFill/>
+          </a:ln>
+        </p:spPr>
+        <p:style>
+          <a:lnRef idx="2">
+            <a:schemeClr val="accent1">
+              <a:shade val="50000"/>
+            </a:schemeClr>
+          </a:lnRef>
+          <a:fillRef idx="1">
+            <a:schemeClr val="accent1"/>
+          </a:fillRef>
+          <a:effectRef idx="0">
+            <a:schemeClr val="accent1"/>
+          </a:effectRef>
+          <a:fontRef idx="minor">
+            <a:schemeClr val="lt1"/>
+          </a:fontRef>
+        </p:style>
+        <p:txBody>
+          <a:bodyPr rtlCol="0" anchor="ctr"/>
+          <a:lstStyle/>
+          <a:p>
+            <a:pPr algn="ctr"/>
+            <a:endParaRPr lang="zh-TW" altLang="en-US"/>
+          </a:p>
+        </p:txBody>
+      </p:sp>
+      <p:sp>
+        <p:nvSpPr>
+          <p:cNvPr id="8" name="橢圓 7">
+            <a:extLst>
+              <a:ext uri="{FF2B5EF4-FFF2-40B4-BE49-F238E27FC236}">
+                <a16:creationId xmlns:a16="http://schemas.microsoft.com/office/drawing/2014/main" id="{6D3C8438-FCD5-4226-8063-0F9A27562C39}"/>
+              </a:ext>
+            </a:extLst>
+          </p:cNvPr>
+          <p:cNvSpPr/>
+          <p:nvPr/>
+        </p:nvSpPr>
+        <p:spPr>
+          <a:xfrm>
+            <a:off x="2835137" y="4134942"/>
+            <a:ext cx="64195" cy="130629"/>
+          </a:xfrm>
+          <a:prstGeom prst="ellipse">
+            <a:avLst/>
+          </a:prstGeom>
+          <a:solidFill>
+            <a:srgbClr val="5B9BD5"/>
+          </a:solidFill>
+          <a:ln>
+            <a:noFill/>
+          </a:ln>
+        </p:spPr>
+        <p:style>
+          <a:lnRef idx="2">
+            <a:schemeClr val="accent1">
+              <a:shade val="50000"/>
+            </a:schemeClr>
+          </a:lnRef>
+          <a:fillRef idx="1">
+            <a:schemeClr val="accent1"/>
+          </a:fillRef>
+          <a:effectRef idx="0">
+            <a:schemeClr val="accent1"/>
+          </a:effectRef>
+          <a:fontRef idx="minor">
+            <a:schemeClr val="lt1"/>
+          </a:fontRef>
+        </p:style>
+        <p:txBody>
+          <a:bodyPr rtlCol="0" anchor="ctr"/>
+          <a:lstStyle/>
+          <a:p>
+            <a:pPr algn="ctr"/>
+            <a:endParaRPr lang="zh-TW" altLang="en-US"/>
+          </a:p>
+        </p:txBody>
+      </p:sp>
+      <p:sp>
+        <p:nvSpPr>
+          <p:cNvPr id="9" name="橢圓 8">
+            <a:extLst>
+              <a:ext uri="{FF2B5EF4-FFF2-40B4-BE49-F238E27FC236}">
+                <a16:creationId xmlns:a16="http://schemas.microsoft.com/office/drawing/2014/main" id="{96104425-61E0-4D8C-B372-C365921C5486}"/>
+              </a:ext>
+            </a:extLst>
+          </p:cNvPr>
+          <p:cNvSpPr/>
+          <p:nvPr/>
+        </p:nvSpPr>
+        <p:spPr>
+          <a:xfrm>
+            <a:off x="3414817" y="4143107"/>
+            <a:ext cx="64195" cy="130629"/>
+          </a:xfrm>
+          <a:prstGeom prst="ellipse">
+            <a:avLst/>
+          </a:prstGeom>
+          <a:solidFill>
+            <a:srgbClr val="FFC000"/>
+          </a:solidFill>
+          <a:ln>
+            <a:noFill/>
+          </a:ln>
+        </p:spPr>
+        <p:style>
+          <a:lnRef idx="2">
+            <a:schemeClr val="accent1">
+              <a:shade val="50000"/>
+            </a:schemeClr>
+          </a:lnRef>
+          <a:fillRef idx="1">
+            <a:schemeClr val="accent1"/>
+          </a:fillRef>
+          <a:effectRef idx="0">
+            <a:schemeClr val="accent1"/>
+          </a:effectRef>
+          <a:fontRef idx="minor">
+            <a:schemeClr val="lt1"/>
+          </a:fontRef>
+        </p:style>
+        <p:txBody>
+          <a:bodyPr rtlCol="0" anchor="ctr"/>
+          <a:lstStyle/>
+          <a:p>
+            <a:pPr algn="ctr"/>
+            <a:endParaRPr lang="zh-TW" altLang="en-US"/>
+          </a:p>
+        </p:txBody>
+      </p:sp>
+      <p:sp>
+        <p:nvSpPr>
+          <p:cNvPr id="11" name="橢圓 10">
+            <a:extLst>
+              <a:ext uri="{FF2B5EF4-FFF2-40B4-BE49-F238E27FC236}">
+                <a16:creationId xmlns:a16="http://schemas.microsoft.com/office/drawing/2014/main" id="{7558CA32-D735-41C5-925C-165913636502}"/>
+              </a:ext>
+            </a:extLst>
+          </p:cNvPr>
+          <p:cNvSpPr/>
+          <p:nvPr/>
+        </p:nvSpPr>
+        <p:spPr>
+          <a:xfrm>
+            <a:off x="3917818" y="4124057"/>
+            <a:ext cx="64195" cy="130629"/>
+          </a:xfrm>
+          <a:prstGeom prst="ellipse">
+            <a:avLst/>
+          </a:prstGeom>
+          <a:solidFill>
+            <a:srgbClr val="ED7D31"/>
+          </a:solidFill>
+          <a:ln>
+            <a:noFill/>
+          </a:ln>
+        </p:spPr>
+        <p:style>
+          <a:lnRef idx="2">
+            <a:schemeClr val="accent1">
+              <a:shade val="50000"/>
+            </a:schemeClr>
+          </a:lnRef>
+          <a:fillRef idx="1">
+            <a:schemeClr val="accent1"/>
+          </a:fillRef>
+          <a:effectRef idx="0">
+            <a:schemeClr val="accent1"/>
+          </a:effectRef>
+          <a:fontRef idx="minor">
+            <a:schemeClr val="lt1"/>
+          </a:fontRef>
+        </p:style>
+        <p:txBody>
+          <a:bodyPr rtlCol="0" anchor="ctr"/>
+          <a:lstStyle/>
+          <a:p>
+            <a:pPr algn="ctr"/>
+            <a:endParaRPr lang="zh-TW" altLang="en-US"/>
+          </a:p>
+        </p:txBody>
+      </p:sp>
+      <p:sp>
+        <p:nvSpPr>
+          <p:cNvPr id="12" name="橢圓 11">
+            <a:extLst>
+              <a:ext uri="{FF2B5EF4-FFF2-40B4-BE49-F238E27FC236}">
+                <a16:creationId xmlns:a16="http://schemas.microsoft.com/office/drawing/2014/main" id="{12DFAB26-4C50-4D43-B300-7CBD574F3234}"/>
+              </a:ext>
+            </a:extLst>
+          </p:cNvPr>
+          <p:cNvSpPr/>
+          <p:nvPr/>
+        </p:nvSpPr>
+        <p:spPr>
+          <a:xfrm>
+            <a:off x="4421855" y="4139677"/>
+            <a:ext cx="64195" cy="130629"/>
+          </a:xfrm>
+          <a:prstGeom prst="ellipse">
+            <a:avLst/>
+          </a:prstGeom>
+          <a:solidFill>
+            <a:srgbClr val="4472C4"/>
+          </a:solidFill>
+          <a:ln>
+            <a:noFill/>
+          </a:ln>
+        </p:spPr>
+        <p:style>
+          <a:lnRef idx="2">
+            <a:schemeClr val="accent1">
+              <a:shade val="50000"/>
+            </a:schemeClr>
+          </a:lnRef>
+          <a:fillRef idx="1">
+            <a:schemeClr val="accent1"/>
+          </a:fillRef>
+          <a:effectRef idx="0">
+            <a:schemeClr val="accent1"/>
+          </a:effectRef>
+          <a:fontRef idx="minor">
+            <a:schemeClr val="lt1"/>
+          </a:fontRef>
+        </p:style>
+        <p:txBody>
+          <a:bodyPr rtlCol="0" anchor="ctr"/>
+          <a:lstStyle/>
+          <a:p>
+            <a:pPr algn="ctr"/>
+            <a:endParaRPr lang="zh-TW" altLang="en-US"/>
+          </a:p>
+        </p:txBody>
+      </p:sp>
+    </p:spTree>
+    <p:extLst>
+      <p:ext uri="{BB962C8B-B14F-4D97-AF65-F5344CB8AC3E}">
+        <p14:creationId xmlns:p14="http://schemas.microsoft.com/office/powerpoint/2010/main" val="54885415"/>
       </p:ext>
     </p:extLst>
   </p:cSld>

</xml_diff>